<commit_message>
add objectives completeness and pptx
</commit_message>
<xml_diff>
--- a/src/report_generator/presets/templates/hygiene-report.pptx
+++ b/src/report_generator/presets/templates/hygiene-report.pptx
@@ -207,7 +207,7 @@
             <c:invertIfNegative val="0"/>
             <c:bubble3D val="0"/>
             <c:explosion val="6"/>
-            <c:extLst xmlns:w="http://schemas.openxmlformats.org/wordprocessingml/2006/main" xmlns:w15="http://schemas.microsoft.com/office/word/2012/wordml" xmlns:w14="http://schemas.microsoft.com/office/word/2010/wordml" xmlns:m="http://schemas.openxmlformats.org/officeDocument/2006/math" xmlns:wp="http://schemas.openxmlformats.org/drawingml/2006/wordprocessingDrawing" xmlns:wp14="http://schemas.microsoft.com/office/word/2010/wordprocessingDrawing" xmlns:mc="http://schemas.openxmlformats.org/markup-compatibility/2006" xmlns:sl="http://schemas.openxmlformats.org/schemaLibrary/2006/main" xmlns:wne="http://schemas.microsoft.com/office/word/2006/wordml" xmlns:cdr="http://schemas.openxmlformats.org/drawingml/2006/chartDrawing" xmlns:c14="http://schemas.microsoft.com/office/drawing/2007/8/2/chart" xmlns:dgm="http://schemas.openxmlformats.org/drawingml/2006/diagram" xmlns:pic="http://schemas.openxmlformats.org/drawingml/2006/picture" xmlns:xdr="http://schemas.openxmlformats.org/drawingml/2006/spreadsheetDrawing" xmlns:dsp="http://schemas.microsoft.com/office/drawing/2008/diagram" xmlns:xvml="urn:schemas-microsoft-com:office:excel" xmlns:o="urn:schemas-microsoft-com:office:office" xmlns:v="urn:schemas-microsoft-com:vml" xmlns:w10="urn:schemas-microsoft-com:office:word" xmlns:pvml="urn:schemas-microsoft-com:office:powerpoint" xmlns:cppr="http://schemas.microsoft.com/office/2006/coverPageProps" xmlns:odx="http://opendope.org/xpaths" xmlns:odc="http://opendope.org/conditions" xmlns:odq="http://opendope.org/questions" xmlns:oda="http://opendope.org/answers" xmlns:odi="http://opendope.org/components" xmlns:odgm="http://opendope.org/SmartArt/DataHierarchy" xmlns:b="http://schemas.openxmlformats.org/officeDocument/2006/bibliography" xmlns:wps="http://schemas.microsoft.com/office/word/2010/wordprocessingShape" xmlns:w16se="http://schemas.microsoft.com/office/word/2015/wordml/symex" xmlns:w16cid="http://schemas.microsoft.com/office/word/2016/wordml/cid" xmlns:wetp="http://schemas.microsoft.com/office/webextensions/taskpanes/2010/11" xmlns:we="http://schemas.microsoft.com/office/webextensions/webextension/2010/11" xmlns:comp="http://schemas.openxmlformats.org/drawingml/2006/compatibility" xmlns:lc="http://schemas.openxmlformats.org/drawingml/2006/lockedCanvas">
+            <c:extLst xmlns:lc="http://schemas.openxmlformats.org/drawingml/2006/lockedCanvas" xmlns:comp="http://schemas.openxmlformats.org/drawingml/2006/compatibility" xmlns:we="http://schemas.microsoft.com/office/webextensions/webextension/2010/11" xmlns:wetp="http://schemas.microsoft.com/office/webextensions/taskpanes/2010/11" xmlns:w16cid="http://schemas.microsoft.com/office/word/2016/wordml/cid" xmlns:w16se="http://schemas.microsoft.com/office/word/2015/wordml/symex" xmlns:wps="http://schemas.microsoft.com/office/word/2010/wordprocessingShape" xmlns:b="http://schemas.openxmlformats.org/officeDocument/2006/bibliography" xmlns:odgm="http://opendope.org/SmartArt/DataHierarchy" xmlns:odi="http://opendope.org/components" xmlns:oda="http://opendope.org/answers" xmlns:odq="http://opendope.org/questions" xmlns:odc="http://opendope.org/conditions" xmlns:odx="http://opendope.org/xpaths" xmlns:cppr="http://schemas.microsoft.com/office/2006/coverPageProps" xmlns:pvml="urn:schemas-microsoft-com:office:powerpoint" xmlns:w10="urn:schemas-microsoft-com:office:word" xmlns:v="urn:schemas-microsoft-com:vml" xmlns:o="urn:schemas-microsoft-com:office:office" xmlns:xvml="urn:schemas-microsoft-com:office:excel" xmlns:dsp="http://schemas.microsoft.com/office/drawing/2008/diagram" xmlns:xdr="http://schemas.openxmlformats.org/drawingml/2006/spreadsheetDrawing" xmlns:pic="http://schemas.openxmlformats.org/drawingml/2006/picture" xmlns:dgm="http://schemas.openxmlformats.org/drawingml/2006/diagram" xmlns:c14="http://schemas.microsoft.com/office/drawing/2007/8/2/chart" xmlns:cdr="http://schemas.openxmlformats.org/drawingml/2006/chartDrawing" xmlns:wne="http://schemas.microsoft.com/office/word/2006/wordml" xmlns:sl="http://schemas.openxmlformats.org/schemaLibrary/2006/main" xmlns:mc="http://schemas.openxmlformats.org/markup-compatibility/2006" xmlns:wp14="http://schemas.microsoft.com/office/word/2010/wordprocessingDrawing" xmlns:wp="http://schemas.openxmlformats.org/drawingml/2006/wordprocessingDrawing" xmlns:m="http://schemas.openxmlformats.org/officeDocument/2006/math" xmlns:w14="http://schemas.microsoft.com/office/word/2010/wordml" xmlns:w15="http://schemas.microsoft.com/office/word/2012/wordml" xmlns:w="http://schemas.openxmlformats.org/wordprocessingml/2006/main">
               <c:ext xmlns:c16="http://schemas.microsoft.com/office/drawing/2014/chart" uri="{C3380CC4-5D6E-409C-BE32-E72D297353CC}">
                 <c16:uniqueId val="{00000000-7C96-CF4F-94AD-E08A5CD6D25E}"/>
               </c:ext>
@@ -346,7 +346,7 @@
               </c:numCache>
             </c:numRef>
           </c:val>
-          <c:extLst xmlns:w="http://schemas.openxmlformats.org/wordprocessingml/2006/main" xmlns:w15="http://schemas.microsoft.com/office/word/2012/wordml" xmlns:w14="http://schemas.microsoft.com/office/word/2010/wordml" xmlns:m="http://schemas.openxmlformats.org/officeDocument/2006/math" xmlns:wp="http://schemas.openxmlformats.org/drawingml/2006/wordprocessingDrawing" xmlns:wp14="http://schemas.microsoft.com/office/word/2010/wordprocessingDrawing" xmlns:mc="http://schemas.openxmlformats.org/markup-compatibility/2006" xmlns:sl="http://schemas.openxmlformats.org/schemaLibrary/2006/main" xmlns:wne="http://schemas.microsoft.com/office/word/2006/wordml" xmlns:cdr="http://schemas.openxmlformats.org/drawingml/2006/chartDrawing" xmlns:c14="http://schemas.microsoft.com/office/drawing/2007/8/2/chart" xmlns:dgm="http://schemas.openxmlformats.org/drawingml/2006/diagram" xmlns:pic="http://schemas.openxmlformats.org/drawingml/2006/picture" xmlns:xdr="http://schemas.openxmlformats.org/drawingml/2006/spreadsheetDrawing" xmlns:dsp="http://schemas.microsoft.com/office/drawing/2008/diagram" xmlns:xvml="urn:schemas-microsoft-com:office:excel" xmlns:o="urn:schemas-microsoft-com:office:office" xmlns:v="urn:schemas-microsoft-com:vml" xmlns:w10="urn:schemas-microsoft-com:office:word" xmlns:pvml="urn:schemas-microsoft-com:office:powerpoint" xmlns:cppr="http://schemas.microsoft.com/office/2006/coverPageProps" xmlns:odx="http://opendope.org/xpaths" xmlns:odc="http://opendope.org/conditions" xmlns:odq="http://opendope.org/questions" xmlns:oda="http://opendope.org/answers" xmlns:odi="http://opendope.org/components" xmlns:odgm="http://opendope.org/SmartArt/DataHierarchy" xmlns:b="http://schemas.openxmlformats.org/officeDocument/2006/bibliography" xmlns:wps="http://schemas.microsoft.com/office/word/2010/wordprocessingShape" xmlns:w16se="http://schemas.microsoft.com/office/word/2015/wordml/symex" xmlns:w16cid="http://schemas.microsoft.com/office/word/2016/wordml/cid" xmlns:wetp="http://schemas.microsoft.com/office/webextensions/taskpanes/2010/11" xmlns:we="http://schemas.microsoft.com/office/webextensions/webextension/2010/11" xmlns:comp="http://schemas.openxmlformats.org/drawingml/2006/compatibility" xmlns:lc="http://schemas.openxmlformats.org/drawingml/2006/lockedCanvas">
+          <c:extLst xmlns:lc="http://schemas.openxmlformats.org/drawingml/2006/lockedCanvas" xmlns:comp="http://schemas.openxmlformats.org/drawingml/2006/compatibility" xmlns:we="http://schemas.microsoft.com/office/webextensions/webextension/2010/11" xmlns:wetp="http://schemas.microsoft.com/office/webextensions/taskpanes/2010/11" xmlns:w16cid="http://schemas.microsoft.com/office/word/2016/wordml/cid" xmlns:w16se="http://schemas.microsoft.com/office/word/2015/wordml/symex" xmlns:wps="http://schemas.microsoft.com/office/word/2010/wordprocessingShape" xmlns:b="http://schemas.openxmlformats.org/officeDocument/2006/bibliography" xmlns:odgm="http://opendope.org/SmartArt/DataHierarchy" xmlns:odi="http://opendope.org/components" xmlns:oda="http://opendope.org/answers" xmlns:odq="http://opendope.org/questions" xmlns:odc="http://opendope.org/conditions" xmlns:odx="http://opendope.org/xpaths" xmlns:cppr="http://schemas.microsoft.com/office/2006/coverPageProps" xmlns:pvml="urn:schemas-microsoft-com:office:powerpoint" xmlns:w10="urn:schemas-microsoft-com:office:word" xmlns:v="urn:schemas-microsoft-com:vml" xmlns:o="urn:schemas-microsoft-com:office:office" xmlns:xvml="urn:schemas-microsoft-com:office:excel" xmlns:dsp="http://schemas.microsoft.com/office/drawing/2008/diagram" xmlns:xdr="http://schemas.openxmlformats.org/drawingml/2006/spreadsheetDrawing" xmlns:pic="http://schemas.openxmlformats.org/drawingml/2006/picture" xmlns:dgm="http://schemas.openxmlformats.org/drawingml/2006/diagram" xmlns:c14="http://schemas.microsoft.com/office/drawing/2007/8/2/chart" xmlns:cdr="http://schemas.openxmlformats.org/drawingml/2006/chartDrawing" xmlns:wne="http://schemas.microsoft.com/office/word/2006/wordml" xmlns:sl="http://schemas.openxmlformats.org/schemaLibrary/2006/main" xmlns:mc="http://schemas.openxmlformats.org/markup-compatibility/2006" xmlns:wp14="http://schemas.microsoft.com/office/word/2010/wordprocessingDrawing" xmlns:wp="http://schemas.openxmlformats.org/drawingml/2006/wordprocessingDrawing" xmlns:m="http://schemas.openxmlformats.org/officeDocument/2006/math" xmlns:w14="http://schemas.microsoft.com/office/word/2010/wordml" xmlns:w15="http://schemas.microsoft.com/office/word/2012/wordml" xmlns:w="http://schemas.openxmlformats.org/wordprocessingml/2006/main">
             <c:ext xmlns:c16="http://schemas.microsoft.com/office/drawing/2014/chart" uri="{C3380CC4-5D6E-409C-BE32-E72D297353CC}">
               <c16:uniqueId val="{00000001-7C96-CF4F-94AD-E08A5CD6D25E}"/>
             </c:ext>
@@ -589,7 +589,7 @@
     <c:plotVisOnly val="1"/>
     <c:dispBlanksAs val="gap"/>
     <c:showDLblsOverMax val="0"/>
-    <c:extLst xmlns:w="http://schemas.openxmlformats.org/wordprocessingml/2006/main" xmlns:w15="http://schemas.microsoft.com/office/word/2012/wordml" xmlns:w14="http://schemas.microsoft.com/office/word/2010/wordml" xmlns:m="http://schemas.openxmlformats.org/officeDocument/2006/math" xmlns:wp="http://schemas.openxmlformats.org/drawingml/2006/wordprocessingDrawing" xmlns:wp14="http://schemas.microsoft.com/office/word/2010/wordprocessingDrawing" xmlns:mc="http://schemas.openxmlformats.org/markup-compatibility/2006" xmlns:sl="http://schemas.openxmlformats.org/schemaLibrary/2006/main" xmlns:wne="http://schemas.microsoft.com/office/word/2006/wordml" xmlns:cdr="http://schemas.openxmlformats.org/drawingml/2006/chartDrawing" xmlns:c14="http://schemas.microsoft.com/office/drawing/2007/8/2/chart" xmlns:dgm="http://schemas.openxmlformats.org/drawingml/2006/diagram" xmlns:pic="http://schemas.openxmlformats.org/drawingml/2006/picture" xmlns:xdr="http://schemas.openxmlformats.org/drawingml/2006/spreadsheetDrawing" xmlns:dsp="http://schemas.microsoft.com/office/drawing/2008/diagram" xmlns:xvml="urn:schemas-microsoft-com:office:excel" xmlns:o="urn:schemas-microsoft-com:office:office" xmlns:v="urn:schemas-microsoft-com:vml" xmlns:w10="urn:schemas-microsoft-com:office:word" xmlns:pvml="urn:schemas-microsoft-com:office:powerpoint" xmlns:cppr="http://schemas.microsoft.com/office/2006/coverPageProps" xmlns:odx="http://opendope.org/xpaths" xmlns:odc="http://opendope.org/conditions" xmlns:odq="http://opendope.org/questions" xmlns:oda="http://opendope.org/answers" xmlns:odi="http://opendope.org/components" xmlns:odgm="http://opendope.org/SmartArt/DataHierarchy" xmlns:b="http://schemas.openxmlformats.org/officeDocument/2006/bibliography" xmlns:wps="http://schemas.microsoft.com/office/word/2010/wordprocessingShape" xmlns:w16se="http://schemas.microsoft.com/office/word/2015/wordml/symex" xmlns:w16cid="http://schemas.microsoft.com/office/word/2016/wordml/cid" xmlns:wetp="http://schemas.microsoft.com/office/webextensions/taskpanes/2010/11" xmlns:we="http://schemas.microsoft.com/office/webextensions/webextension/2010/11" xmlns:comp="http://schemas.openxmlformats.org/drawingml/2006/compatibility" xmlns:lc="http://schemas.openxmlformats.org/drawingml/2006/lockedCanvas">
+    <c:extLst xmlns:lc="http://schemas.openxmlformats.org/drawingml/2006/lockedCanvas" xmlns:comp="http://schemas.openxmlformats.org/drawingml/2006/compatibility" xmlns:we="http://schemas.microsoft.com/office/webextensions/webextension/2010/11" xmlns:wetp="http://schemas.microsoft.com/office/webextensions/taskpanes/2010/11" xmlns:w16cid="http://schemas.microsoft.com/office/word/2016/wordml/cid" xmlns:w16se="http://schemas.microsoft.com/office/word/2015/wordml/symex" xmlns:wps="http://schemas.microsoft.com/office/word/2010/wordprocessingShape" xmlns:b="http://schemas.openxmlformats.org/officeDocument/2006/bibliography" xmlns:odgm="http://opendope.org/SmartArt/DataHierarchy" xmlns:odi="http://opendope.org/components" xmlns:oda="http://opendope.org/answers" xmlns:odq="http://opendope.org/questions" xmlns:odc="http://opendope.org/conditions" xmlns:odx="http://opendope.org/xpaths" xmlns:cppr="http://schemas.microsoft.com/office/2006/coverPageProps" xmlns:pvml="urn:schemas-microsoft-com:office:powerpoint" xmlns:w10="urn:schemas-microsoft-com:office:word" xmlns:v="urn:schemas-microsoft-com:vml" xmlns:o="urn:schemas-microsoft-com:office:office" xmlns:xvml="urn:schemas-microsoft-com:office:excel" xmlns:dsp="http://schemas.microsoft.com/office/drawing/2008/diagram" xmlns:xdr="http://schemas.openxmlformats.org/drawingml/2006/spreadsheetDrawing" xmlns:pic="http://schemas.openxmlformats.org/drawingml/2006/picture" xmlns:dgm="http://schemas.openxmlformats.org/drawingml/2006/diagram" xmlns:c14="http://schemas.microsoft.com/office/drawing/2007/8/2/chart" xmlns:cdr="http://schemas.openxmlformats.org/drawingml/2006/chartDrawing" xmlns:wne="http://schemas.microsoft.com/office/word/2006/wordml" xmlns:sl="http://schemas.openxmlformats.org/schemaLibrary/2006/main" xmlns:mc="http://schemas.openxmlformats.org/markup-compatibility/2006" xmlns:wp14="http://schemas.microsoft.com/office/word/2010/wordprocessingDrawing" xmlns:wp="http://schemas.openxmlformats.org/drawingml/2006/wordprocessingDrawing" xmlns:m="http://schemas.openxmlformats.org/officeDocument/2006/math" xmlns:w14="http://schemas.microsoft.com/office/word/2010/wordml" xmlns:w15="http://schemas.microsoft.com/office/word/2012/wordml" xmlns:w="http://schemas.openxmlformats.org/wordprocessingml/2006/main">
       <c:ext xmlns:c16r3="http://schemas.microsoft.com/office/drawing/2017/03/chart" uri="{56B9EC1D-385E-4148-901F-78D8002777C0}">
         <c16r3:dataDisplayOptions16>
           <c16r3:dispNaAsBlank val="1"/>
@@ -2043,16 +2043,16 @@
                   <c:v>Total</c:v>
                 </c:pt>
                 <c:pt idx="1">
-                  <c:v>All capabilities</c:v>
+                  <c:v>All Capabilities</c:v>
                 </c:pt>
                 <c:pt idx="2">
                   <c:v>Maintainability</c:v>
                 </c:pt>
                 <c:pt idx="3">
-                  <c:v>Architecture</c:v>
+                  <c:v>Architecture Quality</c:v>
                 </c:pt>
                 <c:pt idx="4">
-                  <c:v>OSH</c:v>
+                  <c:v>Open Source Health</c:v>
                 </c:pt>
                 <c:pt idx="5">
                   <c:v>Security</c:v>
@@ -5068,7 +5068,7 @@
           <a:p>
             <a:fld id="{C1255C68-584F-174D-BB81-51BF91708794}" type="datetimeFigureOut">
               <a:rPr lang="en-US" smtClean="0"/>
-              <a:t>4/7/26</a:t>
+              <a:t>4/9/26</a:t>
             </a:fld>
             <a:endParaRPr lang="en-US"/>
           </a:p>
@@ -5261,7 +5261,7 @@
           <a:p>
             <a:fld id="{A1EDAAC4-819D-C544-9EA1-C73624CFD70B}" type="datetimeFigureOut">
               <a:rPr lang="en-US" smtClean="0"/>
-              <a:t>4/7/26</a:t>
+              <a:t>4/9/26</a:t>
             </a:fld>
             <a:endParaRPr lang="en-US"/>
           </a:p>
@@ -10001,14 +10001,14 @@
           <p:nvPr>
             <p:extLst>
               <p:ext uri="{D42A27DB-BD31-4B8C-83A1-F6EECF244321}">
-                <p14:modId xmlns:p14="http://schemas.microsoft.com/office/powerpoint/2010/main" val="2738424419"/>
+                <p14:modId xmlns:p14="http://schemas.microsoft.com/office/powerpoint/2010/main" val="3425585759"/>
               </p:ext>
             </p:extLst>
           </p:nvPr>
         </p:nvGraphicFramePr>
         <p:xfrm>
-          <a:off x="2032000" y="2540000"/>
-          <a:ext cx="8128000" cy="3723049"/>
+          <a:off x="1235282" y="2540951"/>
+          <a:ext cx="9719035" cy="3723049"/>
         </p:xfrm>
         <a:graphic>
           <a:graphicData uri="http://schemas.openxmlformats.org/drawingml/2006/chart">
@@ -10969,6 +10969,12 @@
 </file>
 
 <file path=customXml/item1.xml><?xml version="1.0" encoding="utf-8"?>
+<p:properties xmlns:p="http://schemas.microsoft.com/office/2006/metadata/properties" xmlns:xsi="http://www.w3.org/2001/XMLSchema-instance" xmlns:pc="http://schemas.microsoft.com/office/infopath/2007/PartnerControls">
+  <documentManagement/>
+</p:properties>
+</file>
+
+<file path=customXml/item2.xml><?xml version="1.0" encoding="utf-8"?>
 <ct:contentTypeSchema xmlns:ct="http://schemas.microsoft.com/office/2006/metadata/contentType" xmlns:ma="http://schemas.microsoft.com/office/2006/metadata/properties/metaAttributes" ct:_="" ma:_="" ma:contentTypeName="Document" ma:contentTypeID="0x0101004DEF897B6A9E5243A3BAB7B7BDA55B95" ma:contentTypeVersion="3" ma:contentTypeDescription="Een nieuw document maken." ma:contentTypeScope="" ma:versionID="0a97628efbdf127f23042160181f1d9a">
   <xsd:schema xmlns:xsd="http://www.w3.org/2001/XMLSchema" xmlns:xs="http://www.w3.org/2001/XMLSchema" xmlns:p="http://schemas.microsoft.com/office/2006/metadata/properties" xmlns:ns2="444ebd02-7183-4d1c-abe9-f175efe83725" targetNamespace="http://schemas.microsoft.com/office/2006/metadata/properties" ma:root="true" ma:fieldsID="44a7a3b93c857102c842f6fb1da07824" ns2:_="">
     <xsd:import namespace="444ebd02-7183-4d1c-abe9-f175efe83725"/>
@@ -11106,12 +11112,6 @@
 </ct:contentTypeSchema>
 </file>
 
-<file path=customXml/item2.xml><?xml version="1.0" encoding="utf-8"?>
-<p:properties xmlns:p="http://schemas.microsoft.com/office/2006/metadata/properties" xmlns:xsi="http://www.w3.org/2001/XMLSchema-instance" xmlns:pc="http://schemas.microsoft.com/office/infopath/2007/PartnerControls">
-  <documentManagement/>
-</p:properties>
-</file>
-
 <file path=customXml/item3.xml><?xml version="1.0" encoding="utf-8"?>
 <?mso-contentType ?>
 <FormTemplates xmlns="http://schemas.microsoft.com/sharepoint/v3/contenttype/forms">
@@ -11122,6 +11122,22 @@
 </file>
 
 <file path=customXml/itemProps1.xml><?xml version="1.0" encoding="utf-8"?>
+<ds:datastoreItem xmlns:ds="http://schemas.openxmlformats.org/officeDocument/2006/customXml" ds:itemID="{7575A4A2-8818-4F4B-AD30-88D568004514}">
+  <ds:schemaRefs>
+    <ds:schemaRef ds:uri="http://schemas.microsoft.com/office/2006/metadata/properties"/>
+    <ds:schemaRef ds:uri="http://purl.org/dc/elements/1.1/"/>
+    <ds:schemaRef ds:uri="http://schemas.microsoft.com/office/2006/documentManagement/types"/>
+    <ds:schemaRef ds:uri="http://purl.org/dc/terms/"/>
+    <ds:schemaRef ds:uri="http://schemas.microsoft.com/office/infopath/2007/PartnerControls"/>
+    <ds:schemaRef ds:uri="444ebd02-7183-4d1c-abe9-f175efe83725"/>
+    <ds:schemaRef ds:uri="http://schemas.openxmlformats.org/package/2006/metadata/core-properties"/>
+    <ds:schemaRef ds:uri="http://www.w3.org/XML/1998/namespace"/>
+    <ds:schemaRef ds:uri="http://purl.org/dc/dcmitype/"/>
+  </ds:schemaRefs>
+</ds:datastoreItem>
+</file>
+
+<file path=customXml/itemProps2.xml><?xml version="1.0" encoding="utf-8"?>
 <ds:datastoreItem xmlns:ds="http://schemas.openxmlformats.org/officeDocument/2006/customXml" ds:itemID="{3AFAF3E6-8A11-4BDC-9823-6F0ACEBB33D3}">
   <ds:schemaRefs>
     <ds:schemaRef ds:uri="http://schemas.microsoft.com/office/2006/metadata/contentType"/>
@@ -11139,22 +11155,6 @@
 </ds:datastoreItem>
 </file>
 
-<file path=customXml/itemProps2.xml><?xml version="1.0" encoding="utf-8"?>
-<ds:datastoreItem xmlns:ds="http://schemas.openxmlformats.org/officeDocument/2006/customXml" ds:itemID="{7575A4A2-8818-4F4B-AD30-88D568004514}">
-  <ds:schemaRefs>
-    <ds:schemaRef ds:uri="http://schemas.microsoft.com/office/2006/metadata/properties"/>
-    <ds:schemaRef ds:uri="http://purl.org/dc/elements/1.1/"/>
-    <ds:schemaRef ds:uri="http://schemas.microsoft.com/office/2006/documentManagement/types"/>
-    <ds:schemaRef ds:uri="http://purl.org/dc/terms/"/>
-    <ds:schemaRef ds:uri="http://schemas.microsoft.com/office/infopath/2007/PartnerControls"/>
-    <ds:schemaRef ds:uri="444ebd02-7183-4d1c-abe9-f175efe83725"/>
-    <ds:schemaRef ds:uri="http://schemas.openxmlformats.org/package/2006/metadata/core-properties"/>
-    <ds:schemaRef ds:uri="http://www.w3.org/XML/1998/namespace"/>
-    <ds:schemaRef ds:uri="http://purl.org/dc/dcmitype/"/>
-  </ds:schemaRefs>
-</ds:datastoreItem>
-</file>
-
 <file path=customXml/itemProps3.xml><?xml version="1.0" encoding="utf-8"?>
 <ds:datastoreItem xmlns:ds="http://schemas.openxmlformats.org/officeDocument/2006/customXml" ds:itemID="{88AD9160-B56A-4FCD-857D-8AE63521E7FB}">
   <ds:schemaRefs>

</xml_diff>

<commit_message>
Remove treemap layout from hygiene report
</commit_message>
<xml_diff>
--- a/src/report_generator/presets/templates/hygiene-report.pptx
+++ b/src/report_generator/presets/templates/hygiene-report.pptx
@@ -207,7 +207,7 @@
             <c:invertIfNegative val="0"/>
             <c:bubble3D val="0"/>
             <c:explosion val="6"/>
-            <c:extLst xmlns:lc="http://schemas.openxmlformats.org/drawingml/2006/lockedCanvas" xmlns:comp="http://schemas.openxmlformats.org/drawingml/2006/compatibility" xmlns:we="http://schemas.microsoft.com/office/webextensions/webextension/2010/11" xmlns:wetp="http://schemas.microsoft.com/office/webextensions/taskpanes/2010/11" xmlns:w16cid="http://schemas.microsoft.com/office/word/2016/wordml/cid" xmlns:w16se="http://schemas.microsoft.com/office/word/2015/wordml/symex" xmlns:wps="http://schemas.microsoft.com/office/word/2010/wordprocessingShape" xmlns:b="http://schemas.openxmlformats.org/officeDocument/2006/bibliography" xmlns:odgm="http://opendope.org/SmartArt/DataHierarchy" xmlns:odi="http://opendope.org/components" xmlns:oda="http://opendope.org/answers" xmlns:odq="http://opendope.org/questions" xmlns:odc="http://opendope.org/conditions" xmlns:odx="http://opendope.org/xpaths" xmlns:cppr="http://schemas.microsoft.com/office/2006/coverPageProps" xmlns:pvml="urn:schemas-microsoft-com:office:powerpoint" xmlns:w10="urn:schemas-microsoft-com:office:word" xmlns:v="urn:schemas-microsoft-com:vml" xmlns:o="urn:schemas-microsoft-com:office:office" xmlns:xvml="urn:schemas-microsoft-com:office:excel" xmlns:dsp="http://schemas.microsoft.com/office/drawing/2008/diagram" xmlns:xdr="http://schemas.openxmlformats.org/drawingml/2006/spreadsheetDrawing" xmlns:pic="http://schemas.openxmlformats.org/drawingml/2006/picture" xmlns:dgm="http://schemas.openxmlformats.org/drawingml/2006/diagram" xmlns:c14="http://schemas.microsoft.com/office/drawing/2007/8/2/chart" xmlns:cdr="http://schemas.openxmlformats.org/drawingml/2006/chartDrawing" xmlns:wne="http://schemas.microsoft.com/office/word/2006/wordml" xmlns:sl="http://schemas.openxmlformats.org/schemaLibrary/2006/main" xmlns:mc="http://schemas.openxmlformats.org/markup-compatibility/2006" xmlns:wp14="http://schemas.microsoft.com/office/word/2010/wordprocessingDrawing" xmlns:wp="http://schemas.openxmlformats.org/drawingml/2006/wordprocessingDrawing" xmlns:m="http://schemas.openxmlformats.org/officeDocument/2006/math" xmlns:w14="http://schemas.microsoft.com/office/word/2010/wordml" xmlns:w15="http://schemas.microsoft.com/office/word/2012/wordml" xmlns:w="http://schemas.openxmlformats.org/wordprocessingml/2006/main">
+            <c:extLst xmlns:w="http://schemas.openxmlformats.org/wordprocessingml/2006/main" xmlns:w15="http://schemas.microsoft.com/office/word/2012/wordml" xmlns:w14="http://schemas.microsoft.com/office/word/2010/wordml" xmlns:m="http://schemas.openxmlformats.org/officeDocument/2006/math" xmlns:wp="http://schemas.openxmlformats.org/drawingml/2006/wordprocessingDrawing" xmlns:wp14="http://schemas.microsoft.com/office/word/2010/wordprocessingDrawing" xmlns:mc="http://schemas.openxmlformats.org/markup-compatibility/2006" xmlns:sl="http://schemas.openxmlformats.org/schemaLibrary/2006/main" xmlns:wne="http://schemas.microsoft.com/office/word/2006/wordml" xmlns:cdr="http://schemas.openxmlformats.org/drawingml/2006/chartDrawing" xmlns:c14="http://schemas.microsoft.com/office/drawing/2007/8/2/chart" xmlns:dgm="http://schemas.openxmlformats.org/drawingml/2006/diagram" xmlns:pic="http://schemas.openxmlformats.org/drawingml/2006/picture" xmlns:xdr="http://schemas.openxmlformats.org/drawingml/2006/spreadsheetDrawing" xmlns:dsp="http://schemas.microsoft.com/office/drawing/2008/diagram" xmlns:xvml="urn:schemas-microsoft-com:office:excel" xmlns:o="urn:schemas-microsoft-com:office:office" xmlns:v="urn:schemas-microsoft-com:vml" xmlns:w10="urn:schemas-microsoft-com:office:word" xmlns:pvml="urn:schemas-microsoft-com:office:powerpoint" xmlns:cppr="http://schemas.microsoft.com/office/2006/coverPageProps" xmlns:odx="http://opendope.org/xpaths" xmlns:odc="http://opendope.org/conditions" xmlns:odq="http://opendope.org/questions" xmlns:oda="http://opendope.org/answers" xmlns:odi="http://opendope.org/components" xmlns:odgm="http://opendope.org/SmartArt/DataHierarchy" xmlns:b="http://schemas.openxmlformats.org/officeDocument/2006/bibliography" xmlns:wps="http://schemas.microsoft.com/office/word/2010/wordprocessingShape" xmlns:w16se="http://schemas.microsoft.com/office/word/2015/wordml/symex" xmlns:w16cid="http://schemas.microsoft.com/office/word/2016/wordml/cid" xmlns:wetp="http://schemas.microsoft.com/office/webextensions/taskpanes/2010/11" xmlns:we="http://schemas.microsoft.com/office/webextensions/webextension/2010/11" xmlns:comp="http://schemas.openxmlformats.org/drawingml/2006/compatibility" xmlns:lc="http://schemas.openxmlformats.org/drawingml/2006/lockedCanvas">
               <c:ext xmlns:c16="http://schemas.microsoft.com/office/drawing/2014/chart" uri="{C3380CC4-5D6E-409C-BE32-E72D297353CC}">
                 <c16:uniqueId val="{00000000-7C96-CF4F-94AD-E08A5CD6D25E}"/>
               </c:ext>
@@ -346,7 +346,7 @@
               </c:numCache>
             </c:numRef>
           </c:val>
-          <c:extLst xmlns:lc="http://schemas.openxmlformats.org/drawingml/2006/lockedCanvas" xmlns:comp="http://schemas.openxmlformats.org/drawingml/2006/compatibility" xmlns:we="http://schemas.microsoft.com/office/webextensions/webextension/2010/11" xmlns:wetp="http://schemas.microsoft.com/office/webextensions/taskpanes/2010/11" xmlns:w16cid="http://schemas.microsoft.com/office/word/2016/wordml/cid" xmlns:w16se="http://schemas.microsoft.com/office/word/2015/wordml/symex" xmlns:wps="http://schemas.microsoft.com/office/word/2010/wordprocessingShape" xmlns:b="http://schemas.openxmlformats.org/officeDocument/2006/bibliography" xmlns:odgm="http://opendope.org/SmartArt/DataHierarchy" xmlns:odi="http://opendope.org/components" xmlns:oda="http://opendope.org/answers" xmlns:odq="http://opendope.org/questions" xmlns:odc="http://opendope.org/conditions" xmlns:odx="http://opendope.org/xpaths" xmlns:cppr="http://schemas.microsoft.com/office/2006/coverPageProps" xmlns:pvml="urn:schemas-microsoft-com:office:powerpoint" xmlns:w10="urn:schemas-microsoft-com:office:word" xmlns:v="urn:schemas-microsoft-com:vml" xmlns:o="urn:schemas-microsoft-com:office:office" xmlns:xvml="urn:schemas-microsoft-com:office:excel" xmlns:dsp="http://schemas.microsoft.com/office/drawing/2008/diagram" xmlns:xdr="http://schemas.openxmlformats.org/drawingml/2006/spreadsheetDrawing" xmlns:pic="http://schemas.openxmlformats.org/drawingml/2006/picture" xmlns:dgm="http://schemas.openxmlformats.org/drawingml/2006/diagram" xmlns:c14="http://schemas.microsoft.com/office/drawing/2007/8/2/chart" xmlns:cdr="http://schemas.openxmlformats.org/drawingml/2006/chartDrawing" xmlns:wne="http://schemas.microsoft.com/office/word/2006/wordml" xmlns:sl="http://schemas.openxmlformats.org/schemaLibrary/2006/main" xmlns:mc="http://schemas.openxmlformats.org/markup-compatibility/2006" xmlns:wp14="http://schemas.microsoft.com/office/word/2010/wordprocessingDrawing" xmlns:wp="http://schemas.openxmlformats.org/drawingml/2006/wordprocessingDrawing" xmlns:m="http://schemas.openxmlformats.org/officeDocument/2006/math" xmlns:w14="http://schemas.microsoft.com/office/word/2010/wordml" xmlns:w15="http://schemas.microsoft.com/office/word/2012/wordml" xmlns:w="http://schemas.openxmlformats.org/wordprocessingml/2006/main">
+          <c:extLst xmlns:w="http://schemas.openxmlformats.org/wordprocessingml/2006/main" xmlns:w15="http://schemas.microsoft.com/office/word/2012/wordml" xmlns:w14="http://schemas.microsoft.com/office/word/2010/wordml" xmlns:m="http://schemas.openxmlformats.org/officeDocument/2006/math" xmlns:wp="http://schemas.openxmlformats.org/drawingml/2006/wordprocessingDrawing" xmlns:wp14="http://schemas.microsoft.com/office/word/2010/wordprocessingDrawing" xmlns:mc="http://schemas.openxmlformats.org/markup-compatibility/2006" xmlns:sl="http://schemas.openxmlformats.org/schemaLibrary/2006/main" xmlns:wne="http://schemas.microsoft.com/office/word/2006/wordml" xmlns:cdr="http://schemas.openxmlformats.org/drawingml/2006/chartDrawing" xmlns:c14="http://schemas.microsoft.com/office/drawing/2007/8/2/chart" xmlns:dgm="http://schemas.openxmlformats.org/drawingml/2006/diagram" xmlns:pic="http://schemas.openxmlformats.org/drawingml/2006/picture" xmlns:xdr="http://schemas.openxmlformats.org/drawingml/2006/spreadsheetDrawing" xmlns:dsp="http://schemas.microsoft.com/office/drawing/2008/diagram" xmlns:xvml="urn:schemas-microsoft-com:office:excel" xmlns:o="urn:schemas-microsoft-com:office:office" xmlns:v="urn:schemas-microsoft-com:vml" xmlns:w10="urn:schemas-microsoft-com:office:word" xmlns:pvml="urn:schemas-microsoft-com:office:powerpoint" xmlns:cppr="http://schemas.microsoft.com/office/2006/coverPageProps" xmlns:odx="http://opendope.org/xpaths" xmlns:odc="http://opendope.org/conditions" xmlns:odq="http://opendope.org/questions" xmlns:oda="http://opendope.org/answers" xmlns:odi="http://opendope.org/components" xmlns:odgm="http://opendope.org/SmartArt/DataHierarchy" xmlns:b="http://schemas.openxmlformats.org/officeDocument/2006/bibliography" xmlns:wps="http://schemas.microsoft.com/office/word/2010/wordprocessingShape" xmlns:w16se="http://schemas.microsoft.com/office/word/2015/wordml/symex" xmlns:w16cid="http://schemas.microsoft.com/office/word/2016/wordml/cid" xmlns:wetp="http://schemas.microsoft.com/office/webextensions/taskpanes/2010/11" xmlns:we="http://schemas.microsoft.com/office/webextensions/webextension/2010/11" xmlns:comp="http://schemas.openxmlformats.org/drawingml/2006/compatibility" xmlns:lc="http://schemas.openxmlformats.org/drawingml/2006/lockedCanvas">
             <c:ext xmlns:c16="http://schemas.microsoft.com/office/drawing/2014/chart" uri="{C3380CC4-5D6E-409C-BE32-E72D297353CC}">
               <c16:uniqueId val="{00000001-7C96-CF4F-94AD-E08A5CD6D25E}"/>
             </c:ext>
@@ -589,7 +589,7 @@
     <c:plotVisOnly val="1"/>
     <c:dispBlanksAs val="gap"/>
     <c:showDLblsOverMax val="0"/>
-    <c:extLst xmlns:lc="http://schemas.openxmlformats.org/drawingml/2006/lockedCanvas" xmlns:comp="http://schemas.openxmlformats.org/drawingml/2006/compatibility" xmlns:we="http://schemas.microsoft.com/office/webextensions/webextension/2010/11" xmlns:wetp="http://schemas.microsoft.com/office/webextensions/taskpanes/2010/11" xmlns:w16cid="http://schemas.microsoft.com/office/word/2016/wordml/cid" xmlns:w16se="http://schemas.microsoft.com/office/word/2015/wordml/symex" xmlns:wps="http://schemas.microsoft.com/office/word/2010/wordprocessingShape" xmlns:b="http://schemas.openxmlformats.org/officeDocument/2006/bibliography" xmlns:odgm="http://opendope.org/SmartArt/DataHierarchy" xmlns:odi="http://opendope.org/components" xmlns:oda="http://opendope.org/answers" xmlns:odq="http://opendope.org/questions" xmlns:odc="http://opendope.org/conditions" xmlns:odx="http://opendope.org/xpaths" xmlns:cppr="http://schemas.microsoft.com/office/2006/coverPageProps" xmlns:pvml="urn:schemas-microsoft-com:office:powerpoint" xmlns:w10="urn:schemas-microsoft-com:office:word" xmlns:v="urn:schemas-microsoft-com:vml" xmlns:o="urn:schemas-microsoft-com:office:office" xmlns:xvml="urn:schemas-microsoft-com:office:excel" xmlns:dsp="http://schemas.microsoft.com/office/drawing/2008/diagram" xmlns:xdr="http://schemas.openxmlformats.org/drawingml/2006/spreadsheetDrawing" xmlns:pic="http://schemas.openxmlformats.org/drawingml/2006/picture" xmlns:dgm="http://schemas.openxmlformats.org/drawingml/2006/diagram" xmlns:c14="http://schemas.microsoft.com/office/drawing/2007/8/2/chart" xmlns:cdr="http://schemas.openxmlformats.org/drawingml/2006/chartDrawing" xmlns:wne="http://schemas.microsoft.com/office/word/2006/wordml" xmlns:sl="http://schemas.openxmlformats.org/schemaLibrary/2006/main" xmlns:mc="http://schemas.openxmlformats.org/markup-compatibility/2006" xmlns:wp14="http://schemas.microsoft.com/office/word/2010/wordprocessingDrawing" xmlns:wp="http://schemas.openxmlformats.org/drawingml/2006/wordprocessingDrawing" xmlns:m="http://schemas.openxmlformats.org/officeDocument/2006/math" xmlns:w14="http://schemas.microsoft.com/office/word/2010/wordml" xmlns:w15="http://schemas.microsoft.com/office/word/2012/wordml" xmlns:w="http://schemas.openxmlformats.org/wordprocessingml/2006/main">
+    <c:extLst xmlns:w="http://schemas.openxmlformats.org/wordprocessingml/2006/main" xmlns:w15="http://schemas.microsoft.com/office/word/2012/wordml" xmlns:w14="http://schemas.microsoft.com/office/word/2010/wordml" xmlns:m="http://schemas.openxmlformats.org/officeDocument/2006/math" xmlns:wp="http://schemas.openxmlformats.org/drawingml/2006/wordprocessingDrawing" xmlns:wp14="http://schemas.microsoft.com/office/word/2010/wordprocessingDrawing" xmlns:mc="http://schemas.openxmlformats.org/markup-compatibility/2006" xmlns:sl="http://schemas.openxmlformats.org/schemaLibrary/2006/main" xmlns:wne="http://schemas.microsoft.com/office/word/2006/wordml" xmlns:cdr="http://schemas.openxmlformats.org/drawingml/2006/chartDrawing" xmlns:c14="http://schemas.microsoft.com/office/drawing/2007/8/2/chart" xmlns:dgm="http://schemas.openxmlformats.org/drawingml/2006/diagram" xmlns:pic="http://schemas.openxmlformats.org/drawingml/2006/picture" xmlns:xdr="http://schemas.openxmlformats.org/drawingml/2006/spreadsheetDrawing" xmlns:dsp="http://schemas.microsoft.com/office/drawing/2008/diagram" xmlns:xvml="urn:schemas-microsoft-com:office:excel" xmlns:o="urn:schemas-microsoft-com:office:office" xmlns:v="urn:schemas-microsoft-com:vml" xmlns:w10="urn:schemas-microsoft-com:office:word" xmlns:pvml="urn:schemas-microsoft-com:office:powerpoint" xmlns:cppr="http://schemas.microsoft.com/office/2006/coverPageProps" xmlns:odx="http://opendope.org/xpaths" xmlns:odc="http://opendope.org/conditions" xmlns:odq="http://opendope.org/questions" xmlns:oda="http://opendope.org/answers" xmlns:odi="http://opendope.org/components" xmlns:odgm="http://opendope.org/SmartArt/DataHierarchy" xmlns:b="http://schemas.openxmlformats.org/officeDocument/2006/bibliography" xmlns:wps="http://schemas.microsoft.com/office/word/2010/wordprocessingShape" xmlns:w16se="http://schemas.microsoft.com/office/word/2015/wordml/symex" xmlns:w16cid="http://schemas.microsoft.com/office/word/2016/wordml/cid" xmlns:wetp="http://schemas.microsoft.com/office/webextensions/taskpanes/2010/11" xmlns:we="http://schemas.microsoft.com/office/webextensions/webextension/2010/11" xmlns:comp="http://schemas.openxmlformats.org/drawingml/2006/compatibility" xmlns:lc="http://schemas.openxmlformats.org/drawingml/2006/lockedCanvas">
       <c:ext xmlns:c16r3="http://schemas.microsoft.com/office/drawing/2017/03/chart" uri="{56B9EC1D-385E-4148-901F-78D8002777C0}">
         <c16r3:dataDisplayOptions16>
           <c16r3:dispNaAsBlank val="1"/>
@@ -5068,7 +5068,7 @@
           <a:p>
             <a:fld id="{C1255C68-584F-174D-BB81-51BF91708794}" type="datetimeFigureOut">
               <a:rPr lang="en-US" smtClean="0"/>
-              <a:t>5/19/26</a:t>
+              <a:t>9/4/26</a:t>
             </a:fld>
             <a:endParaRPr lang="en-US"/>
           </a:p>
@@ -5261,7 +5261,7 @@
           <a:p>
             <a:fld id="{A1EDAAC4-819D-C544-9EA1-C73624CFD70B}" type="datetimeFigureOut">
               <a:rPr lang="en-US" smtClean="0"/>
-              <a:t>5/19/26</a:t>
+              <a:t>9/4/26</a:t>
             </a:fld>
             <a:endParaRPr lang="en-US"/>
           </a:p>
@@ -7324,351 +7324,6 @@
     <p:extLst>
       <p:ext uri="{BB962C8B-B14F-4D97-AF65-F5344CB8AC3E}">
         <p14:creationId xmlns:p14="http://schemas.microsoft.com/office/powerpoint/2010/main" val="2167060143"/>
-      </p:ext>
-    </p:extLst>
-  </p:cSld>
-  <p:clrMapOvr>
-    <a:masterClrMapping/>
-  </p:clrMapOvr>
-</p:sldLayout>
-</file>
-
-<file path=ppt/slideLayouts/slideLayout4.xml><?xml version="1.0" encoding="utf-8"?>
-<p:sldLayout xmlns:a="http://schemas.openxmlformats.org/drawingml/2006/main" xmlns:r="http://schemas.openxmlformats.org/officeDocument/2006/relationships" xmlns:p="http://schemas.openxmlformats.org/presentationml/2006/main" preserve="1" userDrawn="1">
-  <p:cSld name="Treemap">
-    <p:spTree>
-      <p:nvGrpSpPr>
-        <p:cNvPr id="1" name=""/>
-        <p:cNvGrpSpPr/>
-        <p:nvPr/>
-      </p:nvGrpSpPr>
-      <p:grpSpPr>
-        <a:xfrm>
-          <a:off x="0" y="0"/>
-          <a:ext cx="0" cy="0"/>
-          <a:chOff x="0" y="0"/>
-          <a:chExt cx="0" cy="0"/>
-        </a:xfrm>
-      </p:grpSpPr>
-      <p:sp>
-        <p:nvSpPr>
-          <p:cNvPr id="26" name="Text Placeholder 4">
-            <a:extLst>
-              <a:ext uri="{FF2B5EF4-FFF2-40B4-BE49-F238E27FC236}">
-                <a16:creationId xmlns:a16="http://schemas.microsoft.com/office/drawing/2014/main" id="{CC299468-581B-CC41-8897-C7E1583185E0}"/>
-              </a:ext>
-            </a:extLst>
-          </p:cNvPr>
-          <p:cNvSpPr>
-            <a:spLocks noGrp="1"/>
-          </p:cNvSpPr>
-          <p:nvPr>
-            <p:ph type="body" sz="quarter" idx="12"/>
-          </p:nvPr>
-        </p:nvSpPr>
-        <p:spPr>
-          <a:xfrm>
-            <a:off x="381600" y="129568"/>
-            <a:ext cx="145471" cy="228209"/>
-          </a:xfrm>
-          <a:prstGeom prst="rect">
-            <a:avLst/>
-          </a:prstGeom>
-          <a:gradFill>
-            <a:gsLst>
-              <a:gs pos="0">
-                <a:srgbClr val="F8C716">
-                  <a:alpha val="0"/>
-                </a:srgbClr>
-              </a:gs>
-              <a:gs pos="5000">
-                <a:srgbClr val="F9C716"/>
-              </a:gs>
-            </a:gsLst>
-            <a:lin ang="0" scaled="0"/>
-          </a:gradFill>
-        </p:spPr>
-        <p:txBody>
-          <a:bodyPr wrap="none" lIns="0" tIns="28800" rIns="144000" bIns="28800" anchor="ctr" anchorCtr="0">
-            <a:spAutoFit/>
-          </a:bodyPr>
-          <a:lstStyle>
-            <a:lvl1pPr marL="0" indent="0">
-              <a:buFont typeface="Arial" panose="020B0604020202020204" pitchFamily="34" charset="0"/>
-              <a:buNone/>
-              <a:defRPr lang="en-US" sz="1050" b="0" cap="none" spc="-30" baseline="0" dirty="0">
-                <a:solidFill>
-                  <a:srgbClr val="000000"/>
-                </a:solidFill>
-                <a:latin typeface="Azeret Mono" pitchFamily="2" charset="77"/>
-                <a:ea typeface="TheSans B6 SemiBold" charset="0"/>
-                <a:cs typeface="TheSans B6 SemiBold" charset="0"/>
-              </a:defRPr>
-            </a:lvl1pPr>
-          </a:lstStyle>
-          <a:p>
-            <a:pPr marL="0" lvl="0"/>
-            <a:r>
-              <a:rPr lang="en-US"/>
-              <a:t>Click to edit Master text styles</a:t>
-            </a:r>
-          </a:p>
-        </p:txBody>
-      </p:sp>
-      <p:sp>
-        <p:nvSpPr>
-          <p:cNvPr id="13" name="Content Placeholder 2">
-            <a:extLst>
-              <a:ext uri="{FF2B5EF4-FFF2-40B4-BE49-F238E27FC236}">
-                <a16:creationId xmlns:a16="http://schemas.microsoft.com/office/drawing/2014/main" id="{F750EC08-DA20-234C-8634-75139A014432}"/>
-              </a:ext>
-            </a:extLst>
-          </p:cNvPr>
-          <p:cNvSpPr>
-            <a:spLocks noGrp="1"/>
-          </p:cNvSpPr>
-          <p:nvPr>
-            <p:ph sz="quarter" idx="13" hasCustomPrompt="1"/>
-          </p:nvPr>
-        </p:nvSpPr>
-        <p:spPr>
-          <a:xfrm>
-            <a:off x="154800" y="1411200"/>
-            <a:ext cx="11880000" cy="4842000"/>
-          </a:xfrm>
-        </p:spPr>
-        <p:txBody>
-          <a:bodyPr>
-            <a:noAutofit/>
-          </a:bodyPr>
-          <a:lstStyle>
-            <a:lvl1pPr marL="0" indent="0">
-              <a:buFont typeface="Arial" panose="020B0604020202020204" pitchFamily="34" charset="0"/>
-              <a:buNone/>
-              <a:tabLst/>
-              <a:defRPr/>
-            </a:lvl1pPr>
-          </a:lstStyle>
-          <a:p>
-            <a:pPr lvl="0"/>
-            <a:r>
-              <a:rPr lang="en-US" dirty="0"/>
-              <a:t>Insert content text (headers in bold)</a:t>
-            </a:r>
-          </a:p>
-        </p:txBody>
-      </p:sp>
-      <p:sp>
-        <p:nvSpPr>
-          <p:cNvPr id="3" name="Tijdelijke aanduiding voor dianummer 2">
-            <a:extLst>
-              <a:ext uri="{FF2B5EF4-FFF2-40B4-BE49-F238E27FC236}">
-                <a16:creationId xmlns:a16="http://schemas.microsoft.com/office/drawing/2014/main" id="{EB15F17F-E5AA-EA4C-0903-54596120C54E}"/>
-              </a:ext>
-            </a:extLst>
-          </p:cNvPr>
-          <p:cNvSpPr>
-            <a:spLocks noGrp="1"/>
-          </p:cNvSpPr>
-          <p:nvPr>
-            <p:ph type="sldNum" sz="quarter" idx="15"/>
-          </p:nvPr>
-        </p:nvSpPr>
-        <p:spPr/>
-        <p:txBody>
-          <a:bodyPr/>
-          <a:lstStyle/>
-          <a:p>
-            <a:fld id="{E242BD21-9B61-2246-BCB1-4BE5E1BEBE1C}" type="slidenum">
-              <a:rPr lang="nl-NL" smtClean="0"/>
-              <a:pPr/>
-              <a:t>‹#›</a:t>
-            </a:fld>
-            <a:endParaRPr lang="nl-NL"/>
-          </a:p>
-        </p:txBody>
-      </p:sp>
-      <p:sp>
-        <p:nvSpPr>
-          <p:cNvPr id="4" name="Titel 3">
-            <a:extLst>
-              <a:ext uri="{FF2B5EF4-FFF2-40B4-BE49-F238E27FC236}">
-                <a16:creationId xmlns:a16="http://schemas.microsoft.com/office/drawing/2014/main" id="{2134FAEE-D5F3-DE0B-2810-BA6C3B0DE8A0}"/>
-              </a:ext>
-            </a:extLst>
-          </p:cNvPr>
-          <p:cNvSpPr>
-            <a:spLocks noGrp="1"/>
-          </p:cNvSpPr>
-          <p:nvPr>
-            <p:ph type="title" hasCustomPrompt="1"/>
-          </p:nvPr>
-        </p:nvSpPr>
-        <p:spPr/>
-        <p:txBody>
-          <a:bodyPr/>
-          <a:lstStyle/>
-          <a:p>
-            <a:r>
-              <a:rPr lang="nl-NL" dirty="0" err="1"/>
-              <a:t>Insert</a:t>
-            </a:r>
-            <a:r>
-              <a:rPr lang="nl-NL" dirty="0"/>
-              <a:t> </a:t>
-            </a:r>
-            <a:r>
-              <a:rPr lang="nl-NL" dirty="0" err="1"/>
-              <a:t>key</a:t>
-            </a:r>
-            <a:r>
-              <a:rPr lang="nl-NL" dirty="0"/>
-              <a:t> slide </a:t>
-            </a:r>
-            <a:r>
-              <a:rPr lang="nl-NL" dirty="0" err="1"/>
-              <a:t>message</a:t>
-            </a:r>
-            <a:r>
-              <a:rPr lang="nl-NL" dirty="0"/>
-              <a:t> (</a:t>
-            </a:r>
-            <a:r>
-              <a:rPr lang="nl-NL" dirty="0" err="1"/>
-              <a:t>title</a:t>
-            </a:r>
-            <a:r>
-              <a:rPr lang="nl-NL" dirty="0"/>
-              <a:t>)</a:t>
-            </a:r>
-            <a:endParaRPr lang="en-US" dirty="0"/>
-          </a:p>
-        </p:txBody>
-      </p:sp>
-      <p:sp>
-        <p:nvSpPr>
-          <p:cNvPr id="5" name="Rectangle 4">
-            <a:extLst>
-              <a:ext uri="{FF2B5EF4-FFF2-40B4-BE49-F238E27FC236}">
-                <a16:creationId xmlns:a16="http://schemas.microsoft.com/office/drawing/2014/main" id="{831DF13F-1492-BD13-A6B1-7A914E1FDC59}"/>
-              </a:ext>
-            </a:extLst>
-          </p:cNvPr>
-          <p:cNvSpPr/>
-          <p:nvPr userDrawn="1"/>
-        </p:nvSpPr>
-        <p:spPr>
-          <a:xfrm>
-            <a:off x="0" y="1390132"/>
-            <a:ext cx="12192000" cy="4927867"/>
-          </a:xfrm>
-          <a:prstGeom prst="rect">
-            <a:avLst/>
-          </a:prstGeom>
-          <a:solidFill>
-            <a:schemeClr val="bg1"/>
-          </a:solidFill>
-          <a:ln>
-            <a:noFill/>
-          </a:ln>
-          <a:effectLst>
-            <a:outerShdw blurRad="190500" dist="38100" dir="2700000" algn="tl" rotWithShape="0">
-              <a:prstClr val="black">
-                <a:alpha val="15000"/>
-              </a:prstClr>
-            </a:outerShdw>
-          </a:effectLst>
-        </p:spPr>
-        <p:style>
-          <a:lnRef idx="2">
-            <a:schemeClr val="accent1">
-              <a:shade val="50000"/>
-            </a:schemeClr>
-          </a:lnRef>
-          <a:fillRef idx="1">
-            <a:schemeClr val="accent1"/>
-          </a:fillRef>
-          <a:effectRef idx="0">
-            <a:schemeClr val="accent1"/>
-          </a:effectRef>
-          <a:fontRef idx="minor">
-            <a:schemeClr val="lt1"/>
-          </a:fontRef>
-        </p:style>
-        <p:txBody>
-          <a:bodyPr lIns="731520" tIns="72000" rIns="108000" bIns="72000" rtlCol="0" anchor="ctr"/>
-          <a:lstStyle/>
-          <a:p>
-            <a:endParaRPr lang="nl-NL" sz="1200" b="1" noProof="0" dirty="0">
-              <a:solidFill>
-                <a:schemeClr val="accent1"/>
-              </a:solidFill>
-            </a:endParaRPr>
-          </a:p>
-        </p:txBody>
-      </p:sp>
-      <p:sp>
-        <p:nvSpPr>
-          <p:cNvPr id="7" name="Tijdelijke aanduiding voor voettekst 1">
-            <a:extLst>
-              <a:ext uri="{FF2B5EF4-FFF2-40B4-BE49-F238E27FC236}">
-                <a16:creationId xmlns:a16="http://schemas.microsoft.com/office/drawing/2014/main" id="{A037B3EB-E786-732F-38F1-CF6E5940C1B9}"/>
-              </a:ext>
-            </a:extLst>
-          </p:cNvPr>
-          <p:cNvSpPr>
-            <a:spLocks noGrp="1"/>
-          </p:cNvSpPr>
-          <p:nvPr>
-            <p:ph type="ftr" sz="quarter" idx="14"/>
-          </p:nvPr>
-        </p:nvSpPr>
-        <p:spPr>
-          <a:xfrm>
-            <a:off x="192158" y="6392274"/>
-            <a:ext cx="1763922" cy="370422"/>
-          </a:xfrm>
-          <a:prstGeom prst="rect">
-            <a:avLst/>
-          </a:prstGeom>
-        </p:spPr>
-        <p:txBody>
-          <a:bodyPr/>
-          <a:lstStyle/>
-          <a:p>
-            <a:r>
-              <a:rPr lang="nl-NL" dirty="0" err="1"/>
-              <a:t>Generated</a:t>
-            </a:r>
-            <a:r>
-              <a:rPr lang="nl-NL" dirty="0"/>
-              <a:t> </a:t>
-            </a:r>
-            <a:r>
-              <a:rPr lang="nl-NL" dirty="0" err="1"/>
-              <a:t>with</a:t>
-            </a:r>
-            <a:r>
-              <a:rPr lang="nl-NL" dirty="0"/>
-              <a:t> Sigrid</a:t>
-            </a:r>
-          </a:p>
-          <a:p>
-            <a:r>
-              <a:rPr lang="nl-NL" dirty="0" err="1"/>
-              <a:t>for</a:t>
-            </a:r>
-            <a:r>
-              <a:rPr lang="nl-NL" dirty="0"/>
-              <a:t> CUSTOMER_NAME</a:t>
-            </a:r>
-          </a:p>
-        </p:txBody>
-      </p:sp>
-    </p:spTree>
-    <p:extLst>
-      <p:ext uri="{BB962C8B-B14F-4D97-AF65-F5344CB8AC3E}">
-        <p14:creationId xmlns:p14="http://schemas.microsoft.com/office/powerpoint/2010/main" val="3381798929"/>
       </p:ext>
     </p:extLst>
   </p:cSld>
@@ -8590,7 +8245,7 @@
           <p:nvPr userDrawn="1"/>
         </p:nvPicPr>
         <p:blipFill>
-          <a:blip r:embed="rId6"/>
+          <a:blip r:embed="rId5"/>
           <a:stretch>
             <a:fillRect/>
           </a:stretch>
@@ -8739,7 +8394,6 @@
     <p:sldLayoutId id="2147483669" r:id="rId1"/>
     <p:sldLayoutId id="2147483662" r:id="rId2"/>
     <p:sldLayoutId id="2147483792" r:id="rId3"/>
-    <p:sldLayoutId id="2147483776" r:id="rId4"/>
   </p:sldLayoutIdLst>
   <p:hf hdr="0" dt="0"/>
   <p:txStyles>
@@ -11387,21 +11041,6 @@
 </file>
 
 <file path=customXml/item1.xml><?xml version="1.0" encoding="utf-8"?>
-<?mso-contentType ?>
-<FormTemplates xmlns="http://schemas.microsoft.com/sharepoint/v3/contenttype/forms">
-  <Display>DocumentLibraryForm</Display>
-  <Edit>DocumentLibraryForm</Edit>
-  <New>DocumentLibraryForm</New>
-</FormTemplates>
-</file>
-
-<file path=customXml/item2.xml><?xml version="1.0" encoding="utf-8"?>
-<p:properties xmlns:p="http://schemas.microsoft.com/office/2006/metadata/properties" xmlns:xsi="http://www.w3.org/2001/XMLSchema-instance" xmlns:pc="http://schemas.microsoft.com/office/infopath/2007/PartnerControls">
-  <documentManagement/>
-</p:properties>
-</file>
-
-<file path=customXml/item3.xml><?xml version="1.0" encoding="utf-8"?>
 <ct:contentTypeSchema xmlns:ct="http://schemas.microsoft.com/office/2006/metadata/contentType" xmlns:ma="http://schemas.microsoft.com/office/2006/metadata/properties/metaAttributes" ct:_="" ma:_="" ma:contentTypeName="Document" ma:contentTypeID="0x0101004DEF897B6A9E5243A3BAB7B7BDA55B95" ma:contentTypeVersion="3" ma:contentTypeDescription="Een nieuw document maken." ma:contentTypeScope="" ma:versionID="0a97628efbdf127f23042160181f1d9a">
   <xsd:schema xmlns:xsd="http://www.w3.org/2001/XMLSchema" xmlns:xs="http://www.w3.org/2001/XMLSchema" xmlns:p="http://schemas.microsoft.com/office/2006/metadata/properties" xmlns:ns2="444ebd02-7183-4d1c-abe9-f175efe83725" targetNamespace="http://schemas.microsoft.com/office/2006/metadata/properties" ma:root="true" ma:fieldsID="44a7a3b93c857102c842f6fb1da07824" ns2:_="">
     <xsd:import namespace="444ebd02-7183-4d1c-abe9-f175efe83725"/>
@@ -11539,10 +11178,35 @@
 </ct:contentTypeSchema>
 </file>
 
+<file path=customXml/item2.xml><?xml version="1.0" encoding="utf-8"?>
+<p:properties xmlns:p="http://schemas.microsoft.com/office/2006/metadata/properties" xmlns:xsi="http://www.w3.org/2001/XMLSchema-instance" xmlns:pc="http://schemas.microsoft.com/office/infopath/2007/PartnerControls">
+  <documentManagement/>
+</p:properties>
+</file>
+
+<file path=customXml/item3.xml><?xml version="1.0" encoding="utf-8"?>
+<?mso-contentType ?>
+<FormTemplates xmlns="http://schemas.microsoft.com/sharepoint/v3/contenttype/forms">
+  <Display>DocumentLibraryForm</Display>
+  <Edit>DocumentLibraryForm</Edit>
+  <New>DocumentLibraryForm</New>
+</FormTemplates>
+</file>
+
 <file path=customXml/itemProps1.xml><?xml version="1.0" encoding="utf-8"?>
-<ds:datastoreItem xmlns:ds="http://schemas.openxmlformats.org/officeDocument/2006/customXml" ds:itemID="{88AD9160-B56A-4FCD-857D-8AE63521E7FB}">
+<ds:datastoreItem xmlns:ds="http://schemas.openxmlformats.org/officeDocument/2006/customXml" ds:itemID="{3AFAF3E6-8A11-4BDC-9823-6F0ACEBB33D3}">
   <ds:schemaRefs>
-    <ds:schemaRef ds:uri="http://schemas.microsoft.com/sharepoint/v3/contenttype/forms"/>
+    <ds:schemaRef ds:uri="http://schemas.microsoft.com/office/2006/metadata/contentType"/>
+    <ds:schemaRef ds:uri="http://schemas.microsoft.com/office/2006/metadata/properties/metaAttributes"/>
+    <ds:schemaRef ds:uri="http://www.w3.org/2001/XMLSchema"/>
+    <ds:schemaRef ds:uri="http://schemas.microsoft.com/office/2006/metadata/properties"/>
+    <ds:schemaRef ds:uri="444ebd02-7183-4d1c-abe9-f175efe83725"/>
+    <ds:schemaRef ds:uri="http://schemas.microsoft.com/office/2006/documentManagement/types"/>
+    <ds:schemaRef ds:uri="http://schemas.microsoft.com/office/infopath/2007/PartnerControls"/>
+    <ds:schemaRef ds:uri="http://schemas.openxmlformats.org/package/2006/metadata/core-properties"/>
+    <ds:schemaRef ds:uri="http://purl.org/dc/elements/1.1/"/>
+    <ds:schemaRef ds:uri="http://purl.org/dc/terms/"/>
+    <ds:schemaRef ds:uri="http://schemas.microsoft.com/internal/obd"/>
   </ds:schemaRefs>
 </ds:datastoreItem>
 </file>
@@ -11564,19 +11228,9 @@
 </file>
 
 <file path=customXml/itemProps3.xml><?xml version="1.0" encoding="utf-8"?>
-<ds:datastoreItem xmlns:ds="http://schemas.openxmlformats.org/officeDocument/2006/customXml" ds:itemID="{3AFAF3E6-8A11-4BDC-9823-6F0ACEBB33D3}">
+<ds:datastoreItem xmlns:ds="http://schemas.openxmlformats.org/officeDocument/2006/customXml" ds:itemID="{88AD9160-B56A-4FCD-857D-8AE63521E7FB}">
   <ds:schemaRefs>
-    <ds:schemaRef ds:uri="http://schemas.microsoft.com/office/2006/metadata/contentType"/>
-    <ds:schemaRef ds:uri="http://schemas.microsoft.com/office/2006/metadata/properties/metaAttributes"/>
-    <ds:schemaRef ds:uri="http://www.w3.org/2001/XMLSchema"/>
-    <ds:schemaRef ds:uri="http://schemas.microsoft.com/office/2006/metadata/properties"/>
-    <ds:schemaRef ds:uri="444ebd02-7183-4d1c-abe9-f175efe83725"/>
-    <ds:schemaRef ds:uri="http://schemas.microsoft.com/office/2006/documentManagement/types"/>
-    <ds:schemaRef ds:uri="http://schemas.microsoft.com/office/infopath/2007/PartnerControls"/>
-    <ds:schemaRef ds:uri="http://schemas.openxmlformats.org/package/2006/metadata/core-properties"/>
-    <ds:schemaRef ds:uri="http://purl.org/dc/elements/1.1/"/>
-    <ds:schemaRef ds:uri="http://purl.org/dc/terms/"/>
-    <ds:schemaRef ds:uri="http://schemas.microsoft.com/internal/obd"/>
+    <ds:schemaRef ds:uri="http://schemas.microsoft.com/sharepoint/v3/contenttype/forms"/>
   </ds:schemaRefs>
 </ds:datastoreItem>
 </file>
</xml_diff>